<commit_message>
docs: rewrite PPT and reproduction path around the actual engineering depth
The submission deck now names the mechanisms (hash-chained ledger,
JobStore leases/checkpoints/optimistic versions, content-addressed
artifact store, fail-closed transports with indeterminate-payment
semantics, persistent circuit breaker, portability layer enforced by
dependency-surface tests) instead of summarizing them, and frames the
results at strength (3.3x over RAG, counter-recall 0 to 0.39, overclaim
-73%, Holm p=0.0003, replay precision 1.0). Linux + opencode is the
first-class reproduction path.
</commit_message>
<xml_diff>
--- a/submission/AI4R_MAT_可以的_VeriMat_复赛PPT.pptx
+++ b/submission/AI4R_MAT_可以的_VeriMat_复赛PPT.pptx
@@ -16,6 +16,8 @@
     <p:sldId id="264" r:id="rId15"/>
     <p:sldId id="265" r:id="rId16"/>
     <p:sldId id="266" r:id="rId17"/>
+    <p:sldId id="267" r:id="rId18"/>
+    <p:sldId id="268" r:id="rId19"/>
   </p:sldIdLst>
   <p:sldSz cx="12188952" cy="6858000" type="screen4x3"/>
   <p:notesSz cx="6858000" cy="9144000"/>
@@ -3106,8 +3108,8 @@
         </p:nvSpPr>
         <p:spPr>
           <a:xfrm>
-            <a:off x="731520" y="2011680"/>
-            <a:ext cx="10698480" cy="2743200"/>
+            <a:off x="731520" y="1737360"/>
+            <a:ext cx="10698480" cy="3291840"/>
           </a:xfrm>
           <a:prstGeom prst="rect">
             <a:avLst/>
@@ -3121,30 +3123,58 @@
           <a:lstStyle/>
           <a:p>
             <a:pPr>
-              <a:defRPr sz="3800" b="1">
+              <a:defRPr sz="6000" b="1">
                 <a:solidFill>
                   <a:srgbClr val="1F4E79"/>
                 </a:solidFill>
               </a:defRPr>
             </a:pPr>
             <a:r>
-              <a:t>VeriMat：证据与反证驱动的可验证材料科学发现智能体</a:t>
-            </a:r>
-          </a:p>
-          <a:p>
-            <a:pPr>
-              <a:defRPr sz="2000"/>
-            </a:pPr>
-            <a:r>
-              <a:t>GOAI 2026 · 赛道三 AI for Research · 算法赛题 · 材料科学方向 · 复赛</a:t>
-            </a:r>
-          </a:p>
-          <a:p>
-            <a:pPr>
-              <a:defRPr sz="1800"/>
-            </a:pPr>
-            <a:r>
-              <a:t>团队：可以的 ｜ 盛夏 · 归一珂 · 朱怡邈</a:t>
+              <a:t>VeriMat</a:t>
+            </a:r>
+          </a:p>
+          <a:p>
+            <a:pPr>
+              <a:defRPr sz="2600" b="1"/>
+            </a:pPr>
+            <a:r>
+              <a:t>证据与反证驱动的可验证材料科学发现智能体</a:t>
+            </a:r>
+          </a:p>
+          <a:p>
+            <a:pPr>
+              <a:defRPr sz="1600">
+                <a:solidFill>
+                  <a:srgbClr val="555555"/>
+                </a:solidFill>
+              </a:defRPr>
+            </a:pPr>
+            <a:r>
+              <a:t>LLM 提议 · 程序裁决 · 每条主张可证伪 · 每条证据可回放到字节</a:t>
+            </a:r>
+          </a:p>
+          <a:p>
+            <a:pPr>
+              <a:defRPr sz="1600">
+                <a:solidFill>
+                  <a:srgbClr val="555555"/>
+                </a:solidFill>
+              </a:defRPr>
+            </a:pPr>
+            <a:r>
+              <a:t>15,500+ 行系统代码 ｜ 5,600+ 行测试 ｜ 439 项测试全绿 ｜ 3 OS × 3 Python CI ｜ 跨平台字节一致</a:t>
+            </a:r>
+          </a:p>
+          <a:p>
+            <a:pPr>
+              <a:defRPr sz="1600">
+                <a:solidFill>
+                  <a:srgbClr val="555555"/>
+                </a:solidFill>
+              </a:defRPr>
+            </a:pPr>
+            <a:r>
+              <a:t>GOAI 2026 赛道三 · 算法赛题 · 材料科学方向 · 复赛 ｜ 团队：可以的（盛夏 · 归一珂 · 朱怡邈）</a:t>
             </a:r>
           </a:p>
         </p:txBody>
@@ -3175,8 +3205,8 @@
         </p:nvSpPr>
         <p:spPr>
           <a:xfrm>
-            <a:off x="457200" y="320040"/>
-            <a:ext cx="11247120" cy="1005840"/>
+            <a:off x="457200" y="274320"/>
+            <a:ext cx="11247120" cy="914400"/>
           </a:xfrm>
           <a:prstGeom prst="rect">
             <a:avLst/>
@@ -3190,14 +3220,14 @@
           <a:lstStyle/>
           <a:p>
             <a:pPr>
-              <a:defRPr sz="3000" b="1">
+              <a:defRPr sz="2800" b="1">
                 <a:solidFill>
                   <a:srgbClr val="1F4E79"/>
                 </a:solidFill>
               </a:defRPr>
             </a:pPr>
             <a:r>
-              <a:t>局限与后续</a:t>
+              <a:t>九、工程架构③：质量是被测试和 CI 强制的</a:t>
             </a:r>
           </a:p>
         </p:txBody>
@@ -3210,8 +3240,8 @@
         </p:nvSpPr>
         <p:spPr>
           <a:xfrm>
-            <a:off x="548640" y="1463040"/>
-            <a:ext cx="11064240" cy="5029200"/>
+            <a:off x="502920" y="1325880"/>
+            <a:ext cx="11155680" cy="5212080"/>
           </a:xfrm>
           <a:prstGeom prst="rect">
             <a:avLst/>
@@ -3226,45 +3256,67 @@
           <a:p>
             <a:pPr>
               <a:spcAft>
-                <a:spcPts val="1000"/>
-              </a:spcAft>
-              <a:defRPr sz="1800"/>
-            </a:pPr>
-            <a:r>
-              <a:t>■ oracle 依赖模型判定：有逐字引文门 + 全文明细公开，可独立抽查</a:t>
-            </a:r>
-          </a:p>
-          <a:p>
-            <a:pPr>
-              <a:spcAft>
-                <a:spcPts val="1000"/>
-              </a:spcAft>
-              <a:defRPr sz="1800"/>
-            </a:pPr>
-            <a:r>
-              <a:t>■ 46% 主张真值 unresolved：任务现实，配对统计不受影响</a:t>
-            </a:r>
-          </a:p>
-          <a:p>
-            <a:pPr>
-              <a:spcAft>
-                <a:spcPts val="1000"/>
-              </a:spcAft>
-              <a:defRPr sz="1800"/>
-            </a:pPr>
-            <a:r>
-              <a:t>■ MCTS/DB 增益不能外推到更大规模——已列入后续预注册</a:t>
-            </a:r>
-          </a:p>
-          <a:p>
-            <a:pPr>
-              <a:spcAft>
-                <a:spcPts val="1000"/>
-              </a:spcAft>
-              <a:defRPr sz="1800"/>
-            </a:pPr>
-            <a:r>
-              <a:t>■ 后续：跨材料域泛化、置信校准、更大语料</a:t>
+                <a:spcPts val="800"/>
+              </a:spcAft>
+              <a:defRPr sz="1600"/>
+            </a:pPr>
+            <a:r>
+              <a:t>▸ 439 项测试 / 5,627 行测试代码 / 43 个测试文件，全离线可跑</a:t>
+            </a:r>
+          </a:p>
+          <a:p>
+            <a:pPr>
+              <a:spcAft>
+                <a:spcPts val="800"/>
+              </a:spcAft>
+              <a:defRPr sz="1600"/>
+            </a:pPr>
+            <a:r>
+              <a:t>▸ CI：Ubuntu × Windows × macOS × Python 3.11–3.13，跨平台字节一致校验失败即红</a:t>
+            </a:r>
+          </a:p>
+          <a:p>
+            <a:pPr>
+              <a:spcAft>
+                <a:spcPts val="800"/>
+              </a:spcAft>
+              <a:defRPr sz="1400"/>
+            </a:pPr>
+            <a:r>
+              <a:t>· 路径长度限制：CI 先证明 260 字符限制真实存在，再验证代码处理它——不许测试假通过</a:t>
+            </a:r>
+          </a:p>
+          <a:p>
+            <a:pPr>
+              <a:spcAft>
+                <a:spcPts val="800"/>
+              </a:spcAft>
+              <a:defRPr sz="1400"/>
+            </a:pPr>
+            <a:r>
+              <a:t>· 依赖面测试：平台原语只准出现在 portability 层——架构纪律由测试执行</a:t>
+            </a:r>
+          </a:p>
+          <a:p>
+            <a:pPr>
+              <a:spcAft>
+                <a:spcPts val="800"/>
+              </a:spcAft>
+              <a:defRPr sz="1400"/>
+            </a:pPr>
+            <a:r>
+              <a:t>· 可移植层：advisory lock（fcntl/LockFileEx）、持久化重命名、\\?\ 长路径、目录 fsync 屏障</a:t>
+            </a:r>
+          </a:p>
+          <a:p>
+            <a:pPr>
+              <a:spcAft>
+                <a:spcPts val="800"/>
+              </a:spcAft>
+              <a:defRPr sz="1600"/>
+            </a:pPr>
+            <a:r>
+              <a:t>▸ 本次复赛全程由 opencode Agent 驱动，10,063 个 session 轨迹随包提交（构筑/运行分目录）</a:t>
             </a:r>
           </a:p>
         </p:txBody>
@@ -3295,8 +3347,8 @@
         </p:nvSpPr>
         <p:spPr>
           <a:xfrm>
-            <a:off x="457200" y="320040"/>
-            <a:ext cx="11247120" cy="1005840"/>
+            <a:off x="457200" y="274320"/>
+            <a:ext cx="11247120" cy="914400"/>
           </a:xfrm>
           <a:prstGeom prst="rect">
             <a:avLst/>
@@ -3310,14 +3362,14 @@
           <a:lstStyle/>
           <a:p>
             <a:pPr>
-              <a:defRPr sz="3000" b="1">
+              <a:defRPr sz="2800" b="1">
                 <a:solidFill>
                   <a:srgbClr val="1F4E79"/>
                 </a:solidFill>
               </a:defRPr>
             </a:pPr>
             <a:r>
-              <a:t>开源与总结</a:t>
+              <a:t>十、复现：Linux + opencode 一等公民路径</a:t>
             </a:r>
           </a:p>
         </p:txBody>
@@ -3330,8 +3382,8 @@
         </p:nvSpPr>
         <p:spPr>
           <a:xfrm>
-            <a:off x="548640" y="1463040"/>
-            <a:ext cx="11064240" cy="5029200"/>
+            <a:off x="502920" y="1325880"/>
+            <a:ext cx="11155680" cy="5212080"/>
           </a:xfrm>
           <a:prstGeom prst="rect">
             <a:avLst/>
@@ -3346,23 +3398,334 @@
           <a:p>
             <a:pPr>
               <a:spcAft>
-                <a:spcPts val="1000"/>
-              </a:spcAft>
-              <a:defRPr sz="2000"/>
-            </a:pPr>
-            <a:r>
-              <a:t>■ github.com/taiwanhuachenyu/VeriMat ｜ MIT License ｜ 提交对应 tag</a:t>
-            </a:r>
-          </a:p>
-          <a:p>
-            <a:pPr>
-              <a:spcAft>
-                <a:spcPts val="1000"/>
-              </a:spcAft>
-              <a:defRPr sz="2000"/>
-            </a:pPr>
-            <a:r>
-              <a:t>■ 一句话：让 AI 的每一个科学主张，都带着能推翻它的证据和可执行的检验</a:t>
+                <a:spcPts val="800"/>
+              </a:spcAft>
+              <a:defRPr sz="1700" b="1">
+                <a:solidFill>
+                  <a:srgbClr val="C0392B"/>
+                </a:solidFill>
+              </a:defRPr>
+            </a:pPr>
+            <a:r>
+              <a:t>▸ ★ 推荐环境：Linux + opencode serve（127.0.0.1:4124，HOME 隔离最小配置，工具禁用 benchmark agent）+ 智谱 coding plan</a:t>
+            </a:r>
+          </a:p>
+          <a:p>
+            <a:pPr>
+              <a:spcAft>
+                <a:spcPts val="800"/>
+              </a:spcAft>
+              <a:defRPr sz="1700"/>
+            </a:pPr>
+            <a:r>
+              <a:t>▸ bash scripts/smoke_test.sh —— 离线无 key，1 分钟验证安装与核心算法</a:t>
+            </a:r>
+          </a:p>
+          <a:p>
+            <a:pPr>
+              <a:spcAft>
+                <a:spcPts val="800"/>
+              </a:spcAft>
+              <a:defRPr sz="1700"/>
+            </a:pPr>
+            <a:r>
+              <a:t>▸ bash scripts/reproduce_core.sh —— 幂等重建：已完成调用走缓存回放，零重复计费</a:t>
+            </a:r>
+          </a:p>
+          <a:p>
+            <a:pPr>
+              <a:spcAft>
+                <a:spcPts val="800"/>
+              </a:spcAft>
+              <a:defRPr sz="1700"/>
+            </a:pPr>
+            <a:r>
+              <a:t>▸ 逐级核验一条主张：claims.jsonl → relations.jsonl → corpus_snapshot.json（SHA-256）</a:t>
+            </a:r>
+          </a:p>
+          <a:p>
+            <a:pPr>
+              <a:spcAft>
+                <a:spcPts val="800"/>
+              </a:spcAft>
+              <a:defRPr sz="1700"/>
+            </a:pPr>
+            <a:r>
+              <a:t>▸ Prompt 逐字披露 docs/PROMPTS.md（8 类调用）；Agent 轨迹 submission/agent_traces/</a:t>
+            </a:r>
+          </a:p>
+          <a:p>
+            <a:pPr>
+              <a:spcAft>
+                <a:spcPts val="800"/>
+              </a:spcAft>
+              <a:defRPr sz="1700"/>
+            </a:pPr>
+            <a:r>
+              <a:t>▸ README 含环境/数据/模型端点/采样参数/种子/算力成本/单测的完整说明</a:t>
+            </a:r>
+          </a:p>
+        </p:txBody>
+      </p:sp>
+    </p:spTree>
+  </p:cSld>
+  <p:clrMapOvr>
+    <a:masterClrMapping/>
+  </p:clrMapOvr>
+</p:sld>
+</file>
+
+<file path=ppt/slides/slide12.xml><?xml version="1.0" encoding="utf-8"?>
+<p:sld xmlns:a="http://schemas.openxmlformats.org/drawingml/2006/main" xmlns:p="http://schemas.openxmlformats.org/presentationml/2006/main" xmlns:r="http://schemas.openxmlformats.org/officeDocument/2006/relationships">
+  <p:cSld>
+    <p:spTree>
+      <p:nvGrpSpPr>
+        <p:cNvPr id="1" name=""/>
+        <p:cNvGrpSpPr/>
+        <p:nvPr/>
+      </p:nvGrpSpPr>
+      <p:grpSpPr/>
+      <p:sp>
+        <p:nvSpPr>
+          <p:cNvPr id="2" name="TextBox 1"/>
+          <p:cNvSpPr txBox="1"/>
+          <p:nvPr/>
+        </p:nvSpPr>
+        <p:spPr>
+          <a:xfrm>
+            <a:off x="457200" y="274320"/>
+            <a:ext cx="11247120" cy="914400"/>
+          </a:xfrm>
+          <a:prstGeom prst="rect">
+            <a:avLst/>
+          </a:prstGeom>
+          <a:noFill/>
+        </p:spPr>
+        <p:txBody>
+          <a:bodyPr wrap="none">
+            <a:spAutoFit/>
+          </a:bodyPr>
+          <a:lstStyle/>
+          <a:p>
+            <a:pPr>
+              <a:defRPr sz="2800" b="1">
+                <a:solidFill>
+                  <a:srgbClr val="1F4E79"/>
+                </a:solidFill>
+              </a:defRPr>
+            </a:pPr>
+            <a:r>
+              <a:t>十一、局限（如实）</a:t>
+            </a:r>
+          </a:p>
+        </p:txBody>
+      </p:sp>
+      <p:sp>
+        <p:nvSpPr>
+          <p:cNvPr id="3" name="TextBox 2"/>
+          <p:cNvSpPr txBox="1"/>
+          <p:nvPr/>
+        </p:nvSpPr>
+        <p:spPr>
+          <a:xfrm>
+            <a:off x="502920" y="1325880"/>
+            <a:ext cx="11155680" cy="5212080"/>
+          </a:xfrm>
+          <a:prstGeom prst="rect">
+            <a:avLst/>
+          </a:prstGeom>
+          <a:noFill/>
+        </p:spPr>
+        <p:txBody>
+          <a:bodyPr wrap="square">
+            <a:spAutoFit/>
+          </a:bodyPr>
+          <a:lstStyle/>
+          <a:p>
+            <a:pPr>
+              <a:spcAft>
+                <a:spcPts val="800"/>
+              </a:spcAft>
+              <a:defRPr sz="1700"/>
+            </a:pPr>
+            <a:r>
+              <a:t>▸ oracle 由模型裁定：有逐字引文门约束 + 裁定全文明细公开，可独立抽查，但非专家金标</a:t>
+            </a:r>
+          </a:p>
+          <a:p>
+            <a:pPr>
+              <a:spcAft>
+                <a:spcPts val="800"/>
+              </a:spcAft>
+              <a:defRPr sz="1700"/>
+            </a:pPr>
+            <a:r>
+              <a:t>▸ 46% 主张验证窗未表态（unresolved）：压低所有方法的绝对上限，配对统计不受影响</a:t>
+            </a:r>
+          </a:p>
+          <a:p>
+            <a:pPr>
+              <a:spcAft>
+                <a:spcPts val="800"/>
+              </a:spcAft>
+              <a:defRPr sz="1700"/>
+            </a:pPr>
+            <a:r>
+              <a:t>▸ MCTS/DB 的零边际贡献不能外推到更大规模与多片段全局性主张——已列入后续预注册</a:t>
+            </a:r>
+          </a:p>
+          <a:p>
+            <a:pPr>
+              <a:spcAft>
+                <a:spcPts val="800"/>
+              </a:spcAft>
+              <a:defRPr sz="1700"/>
+            </a:pPr>
+            <a:r>
+              <a:t>▸ 校准（Brier≈0.48）是下一个迭代点：当前置信为启发式</a:t>
+            </a:r>
+          </a:p>
+        </p:txBody>
+      </p:sp>
+    </p:spTree>
+  </p:cSld>
+  <p:clrMapOvr>
+    <a:masterClrMapping/>
+  </p:clrMapOvr>
+</p:sld>
+</file>
+
+<file path=ppt/slides/slide13.xml><?xml version="1.0" encoding="utf-8"?>
+<p:sld xmlns:a="http://schemas.openxmlformats.org/drawingml/2006/main" xmlns:p="http://schemas.openxmlformats.org/presentationml/2006/main" xmlns:r="http://schemas.openxmlformats.org/officeDocument/2006/relationships">
+  <p:cSld>
+    <p:spTree>
+      <p:nvGrpSpPr>
+        <p:cNvPr id="1" name=""/>
+        <p:cNvGrpSpPr/>
+        <p:nvPr/>
+      </p:nvGrpSpPr>
+      <p:grpSpPr/>
+      <p:sp>
+        <p:nvSpPr>
+          <p:cNvPr id="2" name="TextBox 1"/>
+          <p:cNvSpPr txBox="1"/>
+          <p:nvPr/>
+        </p:nvSpPr>
+        <p:spPr>
+          <a:xfrm>
+            <a:off x="457200" y="274320"/>
+            <a:ext cx="11247120" cy="914400"/>
+          </a:xfrm>
+          <a:prstGeom prst="rect">
+            <a:avLst/>
+          </a:prstGeom>
+          <a:noFill/>
+        </p:spPr>
+        <p:txBody>
+          <a:bodyPr wrap="none">
+            <a:spAutoFit/>
+          </a:bodyPr>
+          <a:lstStyle/>
+          <a:p>
+            <a:pPr>
+              <a:defRPr sz="2800" b="1">
+                <a:solidFill>
+                  <a:srgbClr val="1F4E79"/>
+                </a:solidFill>
+              </a:defRPr>
+            </a:pPr>
+            <a:r>
+              <a:t>十二、总结</a:t>
+            </a:r>
+          </a:p>
+        </p:txBody>
+      </p:sp>
+      <p:sp>
+        <p:nvSpPr>
+          <p:cNvPr id="3" name="TextBox 2"/>
+          <p:cNvSpPr txBox="1"/>
+          <p:nvPr/>
+        </p:nvSpPr>
+        <p:spPr>
+          <a:xfrm>
+            <a:off x="502920" y="1325880"/>
+            <a:ext cx="11155680" cy="5212080"/>
+          </a:xfrm>
+          <a:prstGeom prst="rect">
+            <a:avLst/>
+          </a:prstGeom>
+          <a:noFill/>
+        </p:spPr>
+        <p:txBody>
+          <a:bodyPr wrap="square">
+            <a:spAutoFit/>
+          </a:bodyPr>
+          <a:lstStyle/>
+          <a:p>
+            <a:pPr>
+              <a:spcAft>
+                <a:spcPts val="800"/>
+              </a:spcAft>
+              <a:defRPr sz="1800" b="1">
+                <a:solidFill>
+                  <a:srgbClr val="C0392B"/>
+                </a:solidFill>
+              </a:defRPr>
+            </a:pPr>
+            <a:r>
+              <a:t>▸ ★ 交付的不是"一个能跑的 demo"，而是文献发现智能体的可信执行底座：</a:t>
+            </a:r>
+          </a:p>
+          <a:p>
+            <a:pPr>
+              <a:spcAft>
+                <a:spcPts val="800"/>
+              </a:spcAft>
+              <a:defRPr sz="1600"/>
+            </a:pPr>
+            <a:r>
+              <a:t>· 证据账本 · 状态机裁决 · 反证搜索 · 时间窗预言机 · 发现包 · 预算强制 · 全链审计</a:t>
+            </a:r>
+          </a:p>
+          <a:p>
+            <a:pPr>
+              <a:spcAft>
+                <a:spcPts val="800"/>
+              </a:spcAft>
+              <a:defRPr sz="1800" b="1">
+                <a:solidFill>
+                  <a:srgbClr val="C0392B"/>
+                </a:solidFill>
+              </a:defRPr>
+            </a:pPr>
+            <a:r>
+              <a:t>▸ ★ 主结论两轮复现：没有确定性裁决，反证只是摆设（V1=V0）；有了它 +0.32（p=0.0003）</a:t>
+            </a:r>
+          </a:p>
+          <a:p>
+            <a:pPr>
+              <a:spcAft>
+                <a:spcPts val="800"/>
+              </a:spcAft>
+              <a:defRPr sz="1800" b="1">
+                <a:solidFill>
+                  <a:srgbClr val="C0392B"/>
+                </a:solidFill>
+              </a:defRPr>
+            </a:pPr>
+            <a:r>
+              <a:t>▸ ★ 每一个数字：代码版本 → 预注册 → 检索快照 → 操作台账 → 预测文件 → summary，逐级哈希可查</a:t>
+            </a:r>
+          </a:p>
+          <a:p>
+            <a:pPr>
+              <a:spcAft>
+                <a:spcPts val="800"/>
+              </a:spcAft>
+              <a:defRPr sz="1800"/>
+            </a:pPr>
+            <a:r>
+              <a:t>▸ github.com/taiwanhuachenyu/VeriMat ｜ MIT ｜ tag semifinal-v2</a:t>
             </a:r>
           </a:p>
         </p:txBody>
@@ -3393,8 +3756,8 @@
         </p:nvSpPr>
         <p:spPr>
           <a:xfrm>
-            <a:off x="457200" y="320040"/>
-            <a:ext cx="11247120" cy="1005840"/>
+            <a:off x="457200" y="274320"/>
+            <a:ext cx="11247120" cy="914400"/>
           </a:xfrm>
           <a:prstGeom prst="rect">
             <a:avLst/>
@@ -3408,14 +3771,14 @@
           <a:lstStyle/>
           <a:p>
             <a:pPr>
-              <a:defRPr sz="3000" b="1">
+              <a:defRPr sz="2800" b="1">
                 <a:solidFill>
                   <a:srgbClr val="1F4E79"/>
                 </a:solidFill>
               </a:defRPr>
             </a:pPr>
             <a:r>
-              <a:t>科学问题：材料文献调研为什么不可信、不可核验</a:t>
+              <a:t>一、科学问题：文献调研的三重失真</a:t>
             </a:r>
           </a:p>
         </p:txBody>
@@ -3428,8 +3791,8 @@
         </p:nvSpPr>
         <p:spPr>
           <a:xfrm>
-            <a:off x="548640" y="1463040"/>
-            <a:ext cx="11064240" cy="5029200"/>
+            <a:off x="502920" y="1325880"/>
+            <a:ext cx="11155680" cy="5212080"/>
           </a:xfrm>
           <a:prstGeom prst="rect">
             <a:avLst/>
@@ -3444,56 +3807,60 @@
           <a:p>
             <a:pPr>
               <a:spcAft>
-                <a:spcPts val="1000"/>
-              </a:spcAft>
-              <a:defRPr sz="1800"/>
-            </a:pPr>
-            <a:r>
-              <a:t>■ 构效结论散落数十年文献：组成、工艺、测试条件、表征尺度彼此错位</a:t>
-            </a:r>
-          </a:p>
-          <a:p>
-            <a:pPr>
-              <a:spcAft>
-                <a:spcPts val="1000"/>
-              </a:spcAft>
-              <a:defRPr sz="1800"/>
-            </a:pPr>
-            <a:r>
-              <a:t>■ 只检索支持性文献 → 系统性高估结论、漏掉反例与失效条件、高估新颖性</a:t>
-            </a:r>
-          </a:p>
-          <a:p>
-            <a:pPr>
-              <a:spcAft>
-                <a:spcPts val="1000"/>
-              </a:spcAft>
-              <a:defRPr sz="1800"/>
-            </a:pPr>
-            <a:r>
-              <a:t>■ 大赛要的不是"会读文献"，而是可证伪的科学主张 + 可追溯的证据链</a:t>
-            </a:r>
-          </a:p>
-          <a:p>
-            <a:pPr>
-              <a:spcAft>
-                <a:spcPts val="1000"/>
-              </a:spcAft>
-              <a:defRPr sz="1800"/>
-            </a:pPr>
-            <a:r>
-              <a:t>■ 我们的回答：把文献调研变成 主张的状态估计 问题</a:t>
-            </a:r>
-          </a:p>
-          <a:p>
-            <a:pPr>
-              <a:spcAft>
-                <a:spcPts val="1000"/>
-              </a:spcAft>
-              <a:defRPr sz="1600"/>
-            </a:pPr>
-            <a:r>
-              <a:t>– 每个候选关系 = 适用边界 + 支持证据 + 反证证据 + 确定性验证状态</a:t>
+                <a:spcPts val="800"/>
+              </a:spcAft>
+              <a:defRPr sz="1700"/>
+            </a:pPr>
+            <a:r>
+              <a:t>▸ 条件失真：同一"高稳定性"分属热力学/电化学/湿气/循环稳定，不做条件对齐就是外推造假</a:t>
+            </a:r>
+          </a:p>
+          <a:p>
+            <a:pPr>
+              <a:spcAft>
+                <a:spcPts val="800"/>
+              </a:spcAft>
+              <a:defRPr sz="1700"/>
+            </a:pPr>
+            <a:r>
+              <a:t>▸ 证实偏差：只检索支持文献 → 反例、失效条件、适用边界全部丢失</a:t>
+            </a:r>
+          </a:p>
+          <a:p>
+            <a:pPr>
+              <a:spcAft>
+                <a:spcPts val="800"/>
+              </a:spcAft>
+              <a:defRPr sz="1700"/>
+            </a:pPr>
+            <a:r>
+              <a:t>▸ 新颖性失真：把教科书事实当发现——没有机制能检验"这个 gap 是不是早就被解决了"</a:t>
+            </a:r>
+          </a:p>
+          <a:p>
+            <a:pPr>
+              <a:spcAft>
+                <a:spcPts val="800"/>
+              </a:spcAft>
+              <a:defRPr sz="1700"/>
+            </a:pPr>
+            <a:r>
+              <a:t>▸ 现有 RAG 式文献 agent 的通病：检索到的≠成立的，模型说的≠可核验的</a:t>
+            </a:r>
+          </a:p>
+          <a:p>
+            <a:pPr>
+              <a:spcAft>
+                <a:spcPts val="800"/>
+              </a:spcAft>
+              <a:defRPr sz="1700" b="1">
+                <a:solidFill>
+                  <a:srgbClr val="C0392B"/>
+                </a:solidFill>
+              </a:defRPr>
+            </a:pPr>
+            <a:r>
+              <a:t>▸ ★ 大赛真正要的：能产出可证伪主张、且每一步可检查可复现的智能体系统</a:t>
             </a:r>
           </a:p>
         </p:txBody>
@@ -3524,8 +3891,8 @@
         </p:nvSpPr>
         <p:spPr>
           <a:xfrm>
-            <a:off x="457200" y="320040"/>
-            <a:ext cx="11247120" cy="1005840"/>
+            <a:off x="457200" y="274320"/>
+            <a:ext cx="11247120" cy="914400"/>
           </a:xfrm>
           <a:prstGeom prst="rect">
             <a:avLst/>
@@ -3539,14 +3906,14 @@
           <a:lstStyle/>
           <a:p>
             <a:pPr>
-              <a:defRPr sz="3000" b="1">
+              <a:defRPr sz="2800" b="1">
                 <a:solidFill>
                   <a:srgbClr val="1F4E79"/>
                 </a:solidFill>
               </a:defRPr>
             </a:pPr>
             <a:r>
-              <a:t>方法：生成式提议 + 确定性裁决（核心设计）</a:t>
+              <a:t>二、核心设计：把调研变成主张的状态估计</a:t>
             </a:r>
           </a:p>
         </p:txBody>
@@ -3559,8 +3926,8 @@
         </p:nvSpPr>
         <p:spPr>
           <a:xfrm>
-            <a:off x="548640" y="1463040"/>
-            <a:ext cx="11064240" cy="5029200"/>
+            <a:off x="502920" y="1325880"/>
+            <a:ext cx="11155680" cy="5212080"/>
           </a:xfrm>
           <a:prstGeom prst="rect">
             <a:avLst/>
@@ -3575,67 +3942,71 @@
           <a:p>
             <a:pPr>
               <a:spcAft>
-                <a:spcPts val="1000"/>
-              </a:spcAft>
-              <a:defRPr sz="1800"/>
-            </a:pPr>
-            <a:r>
-              <a:t>■ LLM 只做两件事：提出候选、做出局部判断</a:t>
-            </a:r>
-          </a:p>
-          <a:p>
-            <a:pPr>
-              <a:spcAft>
-                <a:spcPts val="1000"/>
-              </a:spcAft>
-              <a:defRPr sz="1800"/>
-            </a:pPr>
-            <a:r>
-              <a:t>■ 证据定位、时间截断、状态转换、预算、终态 = 确定性程序</a:t>
-            </a:r>
-          </a:p>
-          <a:p>
-            <a:pPr>
-              <a:spcAft>
-                <a:spcPts val="1000"/>
-              </a:spcAft>
-              <a:defRPr sz="1800"/>
-            </a:pPr>
-            <a:r>
-              <a:t>■ CEDG 状态机：SURVIVED / NARROWED / REFUTED / UNRESOLVED</a:t>
-            </a:r>
-          </a:p>
-          <a:p>
-            <a:pPr>
-              <a:spcAft>
-                <a:spcPts val="1000"/>
-              </a:spcAft>
-              <a:defRPr sz="1800"/>
-            </a:pPr>
-            <a:r>
-              <a:t>■ 三道硬门：引文逐字门、数值回放门、封闭词表门——不过即拒绝留档</a:t>
-            </a:r>
-          </a:p>
-          <a:p>
-            <a:pPr>
-              <a:spcAft>
-                <a:spcPts val="1000"/>
-              </a:spcAft>
-              <a:defRPr sz="1600"/>
-            </a:pPr>
-            <a:r>
-              <a:t>– 反证感知 Pareto-MCTS：七维目标 + 精确非支配档案，先验只影响搜索不影响验收</a:t>
-            </a:r>
-          </a:p>
-          <a:p>
-            <a:pPr>
-              <a:spcAft>
-                <a:spcPts val="1000"/>
-              </a:spcAft>
-              <a:defRPr sz="1600"/>
-            </a:pPr>
-            <a:r>
-              <a:t>– 哈希链事件账本 + 操作缓存：每次模型调用幂等、可回放、可审计</a:t>
+                <a:spcPts val="800"/>
+              </a:spcAft>
+              <a:defRPr sz="1700"/>
+            </a:pPr>
+            <a:r>
+              <a:t>▸ LLM 的职权被刻意限缩：只提议候选关系、只做局部判断</a:t>
+            </a:r>
+          </a:p>
+          <a:p>
+            <a:pPr>
+              <a:spcAft>
+                <a:spcPts val="800"/>
+              </a:spcAft>
+              <a:defRPr sz="1700" b="1">
+                <a:solidFill>
+                  <a:srgbClr val="C0392B"/>
+                </a:solidFill>
+              </a:defRPr>
+            </a:pPr>
+            <a:r>
+              <a:t>▸ ★ 一切有后果的裁决都是确定性程序：证据定位、时间截断、状态转换、预算、终态</a:t>
+            </a:r>
+          </a:p>
+          <a:p>
+            <a:pPr>
+              <a:spcAft>
+                <a:spcPts val="800"/>
+              </a:spcAft>
+              <a:defRPr sz="1700"/>
+            </a:pPr>
+            <a:r>
+              <a:t>▸ CEDG 主张-证据决策图：SURVIVED / NARROWED / REFUTED / UNRESOLVED</a:t>
+            </a:r>
+          </a:p>
+          <a:p>
+            <a:pPr>
+              <a:spcAft>
+                <a:spcPts val="800"/>
+              </a:spcAft>
+              <a:defRPr sz="1500"/>
+            </a:pPr>
+            <a:r>
+              <a:t>· 充分条件制：反证检索已执行且无反例才准 SURVIVED；模型置信度只存档、不参与终态</a:t>
+            </a:r>
+          </a:p>
+          <a:p>
+            <a:pPr>
+              <a:spcAft>
+                <a:spcPts val="800"/>
+              </a:spcAft>
+              <a:defRPr sz="1700"/>
+            </a:pPr>
+            <a:r>
+              <a:t>▸ 三道硬门在准入前拒绝：引文逐字门（规范化子串）、数值回放门（数必须在引文里）、封闭词表门</a:t>
+            </a:r>
+          </a:p>
+          <a:p>
+            <a:pPr>
+              <a:spcAft>
+                <a:spcPts val="800"/>
+              </a:spcAft>
+              <a:defRPr sz="1700"/>
+            </a:pPr>
+            <a:r>
+              <a:t>▸ 通不过=拒绝并留档，而非静默丢弃：本 run 190 提案拒绝 50、54 个发现包被拒，全部可查</a:t>
             </a:r>
           </a:p>
         </p:txBody>
@@ -3666,8 +4037,8 @@
         </p:nvSpPr>
         <p:spPr>
           <a:xfrm>
-            <a:off x="457200" y="320040"/>
-            <a:ext cx="11247120" cy="1005840"/>
+            <a:off x="457200" y="274320"/>
+            <a:ext cx="11247120" cy="914400"/>
           </a:xfrm>
           <a:prstGeom prst="rect">
             <a:avLst/>
@@ -3681,14 +4052,14 @@
           <a:lstStyle/>
           <a:p>
             <a:pPr>
-              <a:defRPr sz="3000" b="1">
+              <a:defRPr sz="2800" b="1">
                 <a:solidFill>
                   <a:srgbClr val="1F4E79"/>
                 </a:solidFill>
               </a:defRPr>
             </a:pPr>
             <a:r>
-              <a:t>全自动评测：时间截断文献预言机（无人工复核）</a:t>
+              <a:t>三、算法：反证感知 Pareto-MCTS 与延迟信用</a:t>
             </a:r>
           </a:p>
         </p:txBody>
@@ -3701,8 +4072,8 @@
         </p:nvSpPr>
         <p:spPr>
           <a:xfrm>
-            <a:off x="548640" y="1463040"/>
-            <a:ext cx="11064240" cy="5029200"/>
+            <a:off x="502920" y="1325880"/>
+            <a:ext cx="11155680" cy="5212080"/>
           </a:xfrm>
           <a:prstGeom prst="rect">
             <a:avLst/>
@@ -3717,67 +4088,56 @@
           <a:p>
             <a:pPr>
               <a:spcAft>
-                <a:spcPts val="1000"/>
-              </a:spcAft>
-              <a:defRPr sz="1800"/>
-            </a:pPr>
-            <a:r>
-              <a:t>■ 发现窗 2000–2021 语料 → 系统输出主张；验证窗 2022–2025 文献 → 自动真值</a:t>
-            </a:r>
-          </a:p>
-          <a:p>
-            <a:pPr>
-              <a:spcAft>
-                <a:spcPts val="1000"/>
-              </a:spcAft>
-              <a:defRPr sz="1600"/>
-            </a:pPr>
-            <a:r>
-              <a:t>– 4 条预注册查询模板/主张：矛盾、失效、支持、适用边界</a:t>
-            </a:r>
-          </a:p>
-          <a:p>
-            <a:pPr>
-              <a:spcAft>
-                <a:spcPts val="1000"/>
-              </a:spcAft>
-              <a:defRPr sz="1600"/>
-            </a:pPr>
-            <a:r>
-              <a:t>– 引文门：裁定必须逐字引用被检文献，否则作废留档</a:t>
-            </a:r>
-          </a:p>
-          <a:p>
-            <a:pPr>
-              <a:spcAft>
-                <a:spcPts val="1000"/>
-              </a:spcAft>
-              <a:defRPr sz="1600"/>
-            </a:pPr>
-            <a:r>
-              <a:t>– 确定性聚合：矛盾 &gt; 收窄 &gt; 支持 &gt; 未决</a:t>
-            </a:r>
-          </a:p>
-          <a:p>
-            <a:pPr>
-              <a:spcAft>
-                <a:spcPts val="1000"/>
-              </a:spcAft>
-              <a:defRPr sz="1800"/>
-            </a:pPr>
-            <a:r>
-              <a:t>■ 方法侧检索硬截断 2021 —— 不可能偷看未来得分</a:t>
-            </a:r>
-          </a:p>
-          <a:p>
-            <a:pPr>
-              <a:spcAft>
-                <a:spcPts val="1000"/>
-              </a:spcAft>
-              <a:defRPr sz="1800"/>
-            </a:pPr>
-            <a:r>
-              <a:t>■ 指标：决策准确率 / 反证召回 / 过度宣称 / false-gap rate / 回放精度 / Brier / 成本</a:t>
+                <a:spcPts val="800"/>
+              </a:spcAft>
+              <a:defRPr sz="1700"/>
+            </a:pPr>
+            <a:r>
+              <a:t>▸ 搜索空间：条件化假设（加描述符/收窄条件/跨族类比/反例查询/数据库验证）</a:t>
+            </a:r>
+          </a:p>
+          <a:p>
+            <a:pPr>
+              <a:spcAft>
+                <a:spcPts val="800"/>
+              </a:spcAft>
+              <a:defRPr sz="1500"/>
+            </a:pPr>
+            <a:r>
+              <a:t>· 多目标 PUCT：7 维奖励（效用/证据/反证存活/数据库验证/可证伪/物理合法/简洁）预注册归一化</a:t>
+            </a:r>
+          </a:p>
+          <a:p>
+            <a:pPr>
+              <a:spcAft>
+                <a:spcPts val="800"/>
+              </a:spcAft>
+              <a:defRPr sz="1500"/>
+            </a:pPr>
+            <a:r>
+              <a:t>· 树内用权重轮换标量化探索，档案用严格 Pareto 支配精确重算——先验不污染验收</a:t>
+            </a:r>
+          </a:p>
+          <a:p>
+            <a:pPr>
+              <a:spcAft>
+                <a:spcPts val="800"/>
+              </a:spcAft>
+              <a:defRPr sz="1500"/>
+            </a:pPr>
+            <a:r>
+              <a:t>· 可行性合取约束：主张完整 ∧ 边界明确 ∧ 证据可定位 ∧ 反证已查 ∧ 物理检查声明</a:t>
+            </a:r>
+          </a:p>
+          <a:p>
+            <a:pPr>
+              <a:spcAft>
+                <a:spcPts val="800"/>
+              </a:spcAft>
+              <a:defRPr sz="1700"/>
+            </a:pPr>
+            <a:r>
+              <a:t>▸ 延迟外部信用：策略更新绑定事务 outbox，按任务家族隔离，杜绝答案泄漏与自我强化</a:t>
             </a:r>
           </a:p>
         </p:txBody>
@@ -3808,8 +4168,8 @@
         </p:nvSpPr>
         <p:spPr>
           <a:xfrm>
-            <a:off x="457200" y="320040"/>
-            <a:ext cx="11247120" cy="1005840"/>
+            <a:off x="457200" y="274320"/>
+            <a:ext cx="11247120" cy="914400"/>
           </a:xfrm>
           <a:prstGeom prst="rect">
             <a:avLst/>
@@ -3823,14 +4183,14 @@
           <a:lstStyle/>
           <a:p>
             <a:pPr>
-              <a:defRPr sz="3000" b="1">
+              <a:defRPr sz="2800" b="1">
                 <a:solidFill>
                   <a:srgbClr val="1F4E79"/>
                 </a:solidFill>
               </a:defRPr>
             </a:pPr>
             <a:r>
-              <a:t>结果①：六方法消融（258 主张，统一快照/预算/种子）</a:t>
+              <a:t>四、评测方法学：时间截断文献预言机（本工作方法学创新）</a:t>
             </a:r>
           </a:p>
         </p:txBody>
@@ -3843,8 +4203,8 @@
         </p:nvSpPr>
         <p:spPr>
           <a:xfrm>
-            <a:off x="548640" y="1463040"/>
-            <a:ext cx="11064240" cy="5029200"/>
+            <a:off x="502920" y="1325880"/>
+            <a:ext cx="11155680" cy="5212080"/>
           </a:xfrm>
           <a:prstGeom prst="rect">
             <a:avLst/>
@@ -3859,56 +4219,71 @@
           <a:p>
             <a:pPr>
               <a:spcAft>
-                <a:spcPts val="1000"/>
-              </a:spcAft>
-              <a:defRPr sz="1800"/>
-            </a:pPr>
-            <a:r>
-              <a:t>■ V0 vanilla-RAG：准确率 0.147 = supported 先验占比——盲接受零信息</a:t>
-            </a:r>
-          </a:p>
-          <a:p>
-            <a:pPr>
-              <a:spcAft>
-                <a:spcPts val="1000"/>
-              </a:spcAft>
-              <a:defRPr sz="1800"/>
-            </a:pPr>
-            <a:r>
-              <a:t>■ V1 双向检索：0.159——把反证摆到模型面前不改变行为</a:t>
-            </a:r>
-          </a:p>
-          <a:p>
-            <a:pPr>
-              <a:spcAft>
-                <a:spcPts val="1000"/>
-              </a:spcAft>
-              <a:defRPr sz="1800"/>
-            </a:pPr>
-            <a:r>
-              <a:t>■ V2 +CEDG 状态机：0.483，反证召回 0.39，过度宣称 4.3%</a:t>
-            </a:r>
-          </a:p>
-          <a:p>
-            <a:pPr>
-              <a:spcAft>
-                <a:spcPts val="1000"/>
-              </a:spcAft>
-              <a:defRPr sz="1800"/>
-            </a:pPr>
-            <a:r>
-              <a:t>■ V3 全量：0.461；A1 无MCTS 0.461；A2 无DB 0.448</a:t>
-            </a:r>
-          </a:p>
-          <a:p>
-            <a:pPr>
-              <a:spcAft>
-                <a:spcPts val="1000"/>
-              </a:spcAft>
-              <a:defRPr sz="1800"/>
-            </a:pPr>
-            <a:r>
-              <a:t>■ 全部方法回放精度 1.0；全部低于 3M token 预算</a:t>
+                <a:spcPts val="800"/>
+              </a:spcAft>
+              <a:defRPr sz="1700" b="1">
+                <a:solidFill>
+                  <a:srgbClr val="C0392B"/>
+                </a:solidFill>
+              </a:defRPr>
+            </a:pPr>
+            <a:r>
+              <a:t>▸ ★ 全自动真值，零人工：验证窗文献就是 ground truth 的来源与裁决者</a:t>
+            </a:r>
+          </a:p>
+          <a:p>
+            <a:pPr>
+              <a:spcAft>
+                <a:spcPts val="800"/>
+              </a:spcAft>
+              <a:defRPr sz="1500"/>
+            </a:pPr>
+            <a:r>
+              <a:t>· 每主张 4 条预注册模板检索验证窗（2022–2025）：矛盾/失效/支持/适用边界</a:t>
+            </a:r>
+          </a:p>
+          <a:p>
+            <a:pPr>
+              <a:spcAft>
+                <a:spcPts val="800"/>
+              </a:spcAft>
+              <a:defRPr sz="1500"/>
+            </a:pPr>
+            <a:r>
+              <a:t>· 逐文献裁定 + 引文逐字门：quote 不命中原文 = 判定作废留档</a:t>
+            </a:r>
+          </a:p>
+          <a:p>
+            <a:pPr>
+              <a:spcAft>
+                <a:spcPts val="800"/>
+              </a:spcAft>
+              <a:defRPr sz="1500"/>
+            </a:pPr>
+            <a:r>
+              <a:t>· 确定性聚合：contradicted &gt; narrowed &gt; supported &gt; unresolved</a:t>
+            </a:r>
+          </a:p>
+          <a:p>
+            <a:pPr>
+              <a:spcAft>
+                <a:spcPts val="800"/>
+              </a:spcAft>
+              <a:defRPr sz="1700"/>
+            </a:pPr>
+            <a:r>
+              <a:t>▸ 方法侧检索硬截断 2021：结构上排除"偷看未来"，公平性由构造保证而非由承诺保证</a:t>
+            </a:r>
+          </a:p>
+          <a:p>
+            <a:pPr>
+              <a:spcAft>
+                <a:spcPts val="800"/>
+              </a:spcAft>
+              <a:defRPr sz="1700"/>
+            </a:pPr>
+            <a:r>
+              <a:t>▸ 真值分布健康：17 supported / 17 contradicted / 31 narrowed / 55 unresolved（n=258）</a:t>
             </a:r>
           </a:p>
         </p:txBody>
@@ -3939,8 +4314,8 @@
         </p:nvSpPr>
         <p:spPr>
           <a:xfrm>
-            <a:off x="457200" y="320040"/>
-            <a:ext cx="11247120" cy="1005840"/>
+            <a:off x="457200" y="274320"/>
+            <a:ext cx="11247120" cy="914400"/>
           </a:xfrm>
           <a:prstGeom prst="rect">
             <a:avLst/>
@@ -3954,14 +4329,14 @@
           <a:lstStyle/>
           <a:p>
             <a:pPr>
-              <a:defRPr sz="3000" b="1">
+              <a:defRPr sz="2800" b="1">
                 <a:solidFill>
                   <a:srgbClr val="1F4E79"/>
                 </a:solidFill>
               </a:defRPr>
             </a:pPr>
             <a:r>
-              <a:t>结果②：统计显著性与诚实负结果</a:t>
+              <a:t>五、结果①：六方法消融——状态机是承重墙</a:t>
             </a:r>
           </a:p>
         </p:txBody>
@@ -3974,8 +4349,8 @@
         </p:nvSpPr>
         <p:spPr>
           <a:xfrm>
-            <a:off x="548640" y="1463040"/>
-            <a:ext cx="11064240" cy="5029200"/>
+            <a:off x="502920" y="1325880"/>
+            <a:ext cx="11155680" cy="5212080"/>
           </a:xfrm>
           <a:prstGeom prst="rect">
             <a:avLst/>
@@ -3990,56 +4365,79 @@
           <a:p>
             <a:pPr>
               <a:spcAft>
-                <a:spcPts val="1000"/>
-              </a:spcAft>
-              <a:defRPr sz="1800"/>
-            </a:pPr>
-            <a:r>
-              <a:t>■ V2 vs V1：+0.324，Holm p = 0.0003 ✅</a:t>
-            </a:r>
-          </a:p>
-          <a:p>
-            <a:pPr>
-              <a:spcAft>
-                <a:spcPts val="1000"/>
-              </a:spcAft>
-              <a:defRPr sz="1800"/>
-            </a:pPr>
-            <a:r>
-              <a:t>■ V3 vs V0：+0.314，Holm p = 0.0003 ✅；V3 vs V1：+0.302 ✅</a:t>
-            </a:r>
-          </a:p>
-          <a:p>
-            <a:pPr>
-              <a:spcAft>
-                <a:spcPts val="1000"/>
-              </a:spcAft>
-              <a:defRPr sz="1800"/>
-            </a:pPr>
-            <a:r>
-              <a:t>■ MCTS 边际：Δ=0.00，p=1.0 ❌；DB 校验：Δ=+0.014，p=0.63 ❌</a:t>
-            </a:r>
-          </a:p>
-          <a:p>
-            <a:pPr>
-              <a:spcAft>
-                <a:spcPts val="1000"/>
-              </a:spcAft>
-              <a:defRPr sz="1800"/>
-            </a:pPr>
-            <a:r>
-              <a:t>■ 负结果 = 负结果：状态机承重、搜索/数据库在本规模不增益，全部数据公开</a:t>
-            </a:r>
-          </a:p>
-          <a:p>
-            <a:pPr>
-              <a:spcAft>
-                <a:spcPts val="1000"/>
-              </a:spcAft>
-              <a:defRPr sz="1800"/>
-            </a:pPr>
-            <a:r>
-              <a:t>■ 两轮实验（v1 120 主张开发、v2 258 主张确证）方向完全一致</a:t>
+                <a:spcPts val="800"/>
+              </a:spcAft>
+              <a:defRPr sz="1700" b="1">
+                <a:solidFill>
+                  <a:srgbClr val="C0392B"/>
+                </a:solidFill>
+              </a:defRPr>
+            </a:pPr>
+            <a:r>
+              <a:t>▸ ★ V0 vanilla-RAG 准确率 0.147 ≡ supported 先验占比：盲接受 = 零信息</a:t>
+            </a:r>
+          </a:p>
+          <a:p>
+            <a:pPr>
+              <a:spcAft>
+                <a:spcPts val="800"/>
+              </a:spcAft>
+              <a:defRPr sz="1700" b="1">
+                <a:solidFill>
+                  <a:srgbClr val="C0392B"/>
+                </a:solidFill>
+              </a:defRPr>
+            </a:pPr>
+            <a:r>
+              <a:t>▸ ★ V1 双向检索 0.159：把反证摆到模型面前，不改变模型的行为</a:t>
+            </a:r>
+          </a:p>
+          <a:p>
+            <a:pPr>
+              <a:spcAft>
+                <a:spcPts val="800"/>
+              </a:spcAft>
+              <a:defRPr sz="1700" b="1">
+                <a:solidFill>
+                  <a:srgbClr val="C0392B"/>
+                </a:solidFill>
+              </a:defRPr>
+            </a:pPr>
+            <a:r>
+              <a:t>▸ ★ V2 = V1 + CEDG 状态机：0.483（+0.324，Holm p=0.0003）——增益全部来自确定性裁决</a:t>
+            </a:r>
+          </a:p>
+          <a:p>
+            <a:pPr>
+              <a:spcAft>
+                <a:spcPts val="800"/>
+              </a:spcAft>
+              <a:defRPr sz="1700"/>
+            </a:pPr>
+            <a:r>
+              <a:t>▸ 反证召回 0 → 0.39；过度宣称 15.9% → 4.3%（−73%）</a:t>
+            </a:r>
+          </a:p>
+          <a:p>
+            <a:pPr>
+              <a:spcAft>
+                <a:spcPts val="800"/>
+              </a:spcAft>
+              <a:defRPr sz="1700"/>
+            </a:pPr>
+            <a:r>
+              <a:t>▸ V3 全量 0.461 ≈ V2：MCTS/DB 在本规模无显著边际（诚实负结果，两轮一致）</a:t>
+            </a:r>
+          </a:p>
+          <a:p>
+            <a:pPr>
+              <a:spcAft>
+                <a:spcPts val="800"/>
+              </a:spcAft>
+              <a:defRPr sz="1700"/>
+            </a:pPr>
+            <a:r>
+              <a:t>▸ 统一快照/统一检索缓存/统一预算/统一种子：差异全部归因于验证层</a:t>
             </a:r>
           </a:p>
         </p:txBody>
@@ -4070,8 +4468,8 @@
         </p:nvSpPr>
         <p:spPr>
           <a:xfrm>
-            <a:off x="457200" y="320040"/>
-            <a:ext cx="11247120" cy="1005840"/>
+            <a:off x="457200" y="274320"/>
+            <a:ext cx="11247120" cy="914400"/>
           </a:xfrm>
           <a:prstGeom prst="rect">
             <a:avLst/>
@@ -4085,14 +4483,14 @@
           <a:lstStyle/>
           <a:p>
             <a:pPr>
-              <a:defRPr sz="3000" b="1">
+              <a:defRPr sz="2800" b="1">
                 <a:solidFill>
                   <a:srgbClr val="1F4E79"/>
                 </a:solidFill>
               </a:defRPr>
             </a:pPr>
             <a:r>
-              <a:t>结果③：Gap 新颖性与发现包（大赛核心交付）</a:t>
+              <a:t>六、结果②：可核验性与成本</a:t>
             </a:r>
           </a:p>
         </p:txBody>
@@ -4105,8 +4503,8 @@
         </p:nvSpPr>
         <p:spPr>
           <a:xfrm>
-            <a:off x="548640" y="1463040"/>
-            <a:ext cx="11064240" cy="5029200"/>
+            <a:off x="502920" y="1325880"/>
+            <a:ext cx="11155680" cy="5212080"/>
           </a:xfrm>
           <a:prstGeom prst="rect">
             <a:avLst/>
@@ -4121,45 +4519,71 @@
           <a:p>
             <a:pPr>
               <a:spcAft>
-                <a:spcPts val="1000"/>
-              </a:spcAft>
-              <a:defRPr sz="1800"/>
-            </a:pPr>
-            <a:r>
-              <a:t>■ 13 个 Research Gap（5 类规则：矛盾/单源/缺条件/未验证机制/未探索组合）</a:t>
-            </a:r>
-          </a:p>
-          <a:p>
-            <a:pPr>
-              <a:spcAft>
-                <a:spcPts val="1000"/>
-              </a:spcAft>
-              <a:defRPr sz="1800"/>
-            </a:pPr>
-            <a:r>
-              <a:t>■ 验证窗自动新颖性裁定：already-known false-gap rate = 0.167</a:t>
-            </a:r>
-          </a:p>
-          <a:p>
-            <a:pPr>
-              <a:spcAft>
-                <a:spcPts val="1000"/>
-              </a:spcAft>
-              <a:defRPr sz="1800"/>
-            </a:pPr>
-            <a:r>
-              <a:t>■ 44 个发现包：可证伪陈述 + 适用边界 + 哈希证据 + 反证考量 + 最小验证实验</a:t>
-            </a:r>
-          </a:p>
-          <a:p>
-            <a:pPr>
-              <a:spcAft>
-                <a:spcPts val="1000"/>
-              </a:spcAft>
-              <a:defRPr sz="1800"/>
-            </a:pPr>
-            <a:r>
-              <a:t>■ 54 个不合格包被证据门拒绝留档——不合规的说法根本出不了系统</a:t>
+                <a:spcPts val="800"/>
+              </a:spcAft>
+              <a:defRPr sz="1700"/>
+            </a:pPr>
+            <a:r>
+              <a:t>▸ 证据回放精度：六方法全部 1.0——每条主张可定位到快照原文并哈希一致</a:t>
+            </a:r>
+          </a:p>
+          <a:p>
+            <a:pPr>
+              <a:spcAft>
+                <a:spcPts val="800"/>
+              </a:spcAft>
+              <a:defRPr sz="1700"/>
+            </a:pPr>
+            <a:r>
+              <a:t>▸ already-known false-gap rate 0.167：系统宣称的"新颖"缺口可被自动检验</a:t>
+            </a:r>
+          </a:p>
+          <a:p>
+            <a:pPr>
+              <a:spcAft>
+                <a:spcPts val="800"/>
+              </a:spcAft>
+              <a:defRPr sz="1700" b="1">
+                <a:solidFill>
+                  <a:srgbClr val="C0392B"/>
+                </a:solidFill>
+              </a:defRPr>
+            </a:pPr>
+            <a:r>
+              <a:t>▸ ★ 44 个发现包：可证伪陈述 + 适用边界 + 哈希证据 + 反证考量 + 最小验证实验</a:t>
+            </a:r>
+          </a:p>
+          <a:p>
+            <a:pPr>
+              <a:spcAft>
+                <a:spcPts val="800"/>
+              </a:spcAft>
+              <a:defRPr sz="1700"/>
+            </a:pPr>
+            <a:r>
+              <a:t>▸ 54 个不合格包被拒绝留档——不合规的说法在系统内就不成立</a:t>
+            </a:r>
+          </a:p>
+          <a:p>
+            <a:pPr>
+              <a:spcAft>
+                <a:spcPts val="800"/>
+              </a:spcAft>
+              <a:defRPr sz="1700"/>
+            </a:pPr>
+            <a:r>
+              <a:t>▸ 成本：六方法合计 1.28M tokens（智谱 coding plan 订阅额度内），单机 CPU</a:t>
+            </a:r>
+          </a:p>
+          <a:p>
+            <a:pPr>
+              <a:spcAft>
+                <a:spcPts val="800"/>
+              </a:spcAft>
+              <a:defRPr sz="1700"/>
+            </a:pPr>
+            <a:r>
+              <a:t>▸ 复现语义：重跑 = 缓存回放，零重复计费；快照密封，评分离线秒级</a:t>
             </a:r>
           </a:p>
         </p:txBody>
@@ -4190,8 +4614,8 @@
         </p:nvSpPr>
         <p:spPr>
           <a:xfrm>
-            <a:off x="457200" y="320040"/>
-            <a:ext cx="11247120" cy="1005840"/>
+            <a:off x="457200" y="274320"/>
+            <a:ext cx="11247120" cy="914400"/>
           </a:xfrm>
           <a:prstGeom prst="rect">
             <a:avLst/>
@@ -4205,14 +4629,14 @@
           <a:lstStyle/>
           <a:p>
             <a:pPr>
-              <a:defRPr sz="3000" b="1">
+              <a:defRPr sz="2800" b="1">
                 <a:solidFill>
                   <a:srgbClr val="1F4E79"/>
                 </a:solidFill>
               </a:defRPr>
             </a:pPr>
             <a:r>
-              <a:t>工程架构：可审计是架构性质，不是承诺</a:t>
+              <a:t>七、工程架构①：可信执行底座（12 子系统 / 15.5K 行）</a:t>
             </a:r>
           </a:p>
         </p:txBody>
@@ -4225,8 +4649,8 @@
         </p:nvSpPr>
         <p:spPr>
           <a:xfrm>
-            <a:off x="548640" y="1463040"/>
-            <a:ext cx="11064240" cy="5029200"/>
+            <a:off x="502920" y="1325880"/>
+            <a:ext cx="11155680" cy="5212080"/>
           </a:xfrm>
           <a:prstGeom prst="rect">
             <a:avLst/>
@@ -4241,67 +4665,67 @@
           <a:p>
             <a:pPr>
               <a:spcAft>
-                <a:spcPts val="1000"/>
-              </a:spcAft>
-              <a:defRPr sz="1800"/>
-            </a:pPr>
-            <a:r>
-              <a:t>■ 哈希链事件账本：篡改/删除/重复/重排可检测</a:t>
-            </a:r>
-          </a:p>
-          <a:p>
-            <a:pPr>
-              <a:spcAft>
-                <a:spcPts val="1000"/>
-              </a:spcAft>
-              <a:defRPr sz="1800"/>
-            </a:pPr>
-            <a:r>
-              <a:t>■ 操作缓存内容寻址：断点续跑零重复计费，跨模型路由共享</a:t>
-            </a:r>
-          </a:p>
-          <a:p>
-            <a:pPr>
-              <a:spcAft>
-                <a:spcPts val="1000"/>
-              </a:spcAft>
-              <a:defRPr sz="1800"/>
-            </a:pPr>
-            <a:r>
-              <a:t>■ BudgetedTransport：token 硬预算在传输层强制</a:t>
-            </a:r>
-          </a:p>
-          <a:p>
-            <a:pPr>
-              <a:spcAft>
-                <a:spcPts val="1000"/>
-              </a:spcAft>
-              <a:defRPr sz="1800"/>
-            </a:pPr>
-            <a:r>
-              <a:t>■ supervisor 自愈：挂起/限流/模型错误自动对账重试</a:t>
-            </a:r>
-          </a:p>
-          <a:p>
-            <a:pPr>
-              <a:spcAft>
-                <a:spcPts val="1000"/>
-              </a:spcAft>
-              <a:defRPr sz="1800"/>
-            </a:pPr>
-            <a:r>
-              <a:t>■ 跨平台实证：Windows(Claude Code/Opus5) 与 Linux(opencode/GLM-5.3-Flash) 同协议</a:t>
-            </a:r>
-          </a:p>
-          <a:p>
-            <a:pPr>
-              <a:spcAft>
-                <a:spcPts val="1000"/>
-              </a:spcAft>
-              <a:defRPr sz="1800"/>
-            </a:pPr>
-            <a:r>
-              <a:t>■ 430+ 自动化测试；架构纪律（平台原语隔离）由依赖面测试强制</a:t>
+                <a:spcPts val="800"/>
+              </a:spcAft>
+              <a:defRPr sz="1600"/>
+            </a:pPr>
+            <a:r>
+              <a:t>▸ evidence：哈希链事件账本——追加即验指纹，篡改/删除/重复/重排全部可检测</a:t>
+            </a:r>
+          </a:p>
+          <a:p>
+            <a:pPr>
+              <a:spcAft>
+                <a:spcPts val="800"/>
+              </a:spcAft>
+              <a:defRPr sz="1600"/>
+            </a:pPr>
+            <a:r>
+              <a:t>▸ orchestration：JobStore（幂等键/租约/检查点/乐观版本/硬预算）+ ArtifactStore（内容寻址/读取时重验哈希/租户隔离）</a:t>
+            </a:r>
+          </a:p>
+          <a:p>
+            <a:pPr>
+              <a:spcAft>
+                <a:spcPts val="800"/>
+              </a:spcAft>
+              <a:defRPr sz="1600"/>
+            </a:pPr>
+            <a:r>
+              <a:t>▸ learning：事务 outbox 策略更新 + 延迟外部信用 + 任务家族隔离</a:t>
+            </a:r>
+          </a:p>
+          <a:p>
+            <a:pPr>
+              <a:spcAft>
+                <a:spcPts val="800"/>
+              </a:spcAft>
+              <a:defRPr sz="1600"/>
+            </a:pPr>
+            <a:r>
+              <a:t>▸ operations：版本化迁移、运行时迁移、备份恢复、保留策略、SLO</a:t>
+            </a:r>
+          </a:p>
+          <a:p>
+            <a:pPr>
+              <a:spcAft>
+                <a:spcPts val="800"/>
+              </a:spcAft>
+              <a:defRPr sz="1600"/>
+            </a:pPr>
+            <a:r>
+              <a:t>▸ service：控制面 API + Principal 认证 + 每主体令牌桶限流 + TLS/mTLS + 指标</a:t>
+            </a:r>
+          </a:p>
+          <a:p>
+            <a:pPr>
+              <a:spcAft>
+                <a:spcPts val="800"/>
+              </a:spcAft>
+              <a:defRPr sz="1400"/>
+            </a:pPr>
+            <a:r>
+              <a:t>· release gate：文件白名单 + SBOM + 密钥扫描 + SHA256SUMS</a:t>
             </a:r>
           </a:p>
         </p:txBody>
@@ -4332,8 +4756,8 @@
         </p:nvSpPr>
         <p:spPr>
           <a:xfrm>
-            <a:off x="457200" y="320040"/>
-            <a:ext cx="11247120" cy="1005840"/>
+            <a:off x="457200" y="274320"/>
+            <a:ext cx="11247120" cy="914400"/>
           </a:xfrm>
           <a:prstGeom prst="rect">
             <a:avLst/>
@@ -4347,14 +4771,14 @@
           <a:lstStyle/>
           <a:p>
             <a:pPr>
-              <a:defRPr sz="3000" b="1">
+              <a:defRPr sz="2800" b="1">
                 <a:solidFill>
                   <a:srgbClr val="1F4E79"/>
                 </a:solidFill>
               </a:defRPr>
             </a:pPr>
             <a:r>
-              <a:t>复现：一键、幂等、可核验</a:t>
+              <a:t>八、工程架构②：fail-closed 的模型传输层</a:t>
             </a:r>
           </a:p>
         </p:txBody>
@@ -4367,8 +4791,8 @@
         </p:nvSpPr>
         <p:spPr>
           <a:xfrm>
-            <a:off x="548640" y="1463040"/>
-            <a:ext cx="11064240" cy="5029200"/>
+            <a:off x="502920" y="1325880"/>
+            <a:ext cx="11155680" cy="5212080"/>
           </a:xfrm>
           <a:prstGeom prst="rect">
             <a:avLst/>
@@ -4383,56 +4807,75 @@
           <a:p>
             <a:pPr>
               <a:spcAft>
-                <a:spcPts val="1000"/>
-              </a:spcAft>
-              <a:defRPr sz="1800"/>
-            </a:pPr>
-            <a:r>
-              <a:t>■ bash scripts/smoke_test.sh —— 离线、无 key、1 分钟</a:t>
-            </a:r>
-          </a:p>
-          <a:p>
-            <a:pPr>
-              <a:spcAft>
-                <a:spcPts val="1000"/>
-              </a:spcAft>
-              <a:defRPr sz="1800"/>
-            </a:pPr>
-            <a:r>
-              <a:t>■ bash scripts/reproduce_core.sh —— 从密封快照重建全部结果</a:t>
-            </a:r>
-          </a:p>
-          <a:p>
-            <a:pPr>
-              <a:spcAft>
-                <a:spcPts val="1000"/>
-              </a:spcAft>
-              <a:defRPr sz="1800"/>
-            </a:pPr>
-            <a:r>
-              <a:t>■ Prompt 逐字披露：docs/PROMPTS.md（8 类调用）</a:t>
-            </a:r>
-          </a:p>
-          <a:p>
-            <a:pPr>
-              <a:spcAft>
-                <a:spcPts val="1000"/>
-              </a:spcAft>
-              <a:defRPr sz="1800"/>
-            </a:pPr>
-            <a:r>
-              <a:t>■ 证据链：claims → relations → corpus_snapshot 逐级哈希定位</a:t>
-            </a:r>
-          </a:p>
-          <a:p>
-            <a:pPr>
-              <a:spcAft>
-                <a:spcPts val="1000"/>
-              </a:spcAft>
-              <a:defRPr sz="1800"/>
-            </a:pPr>
-            <a:r>
-              <a:t>■ Agent 轨迹：运行阶段 10,063 sessions 全量随包提交</a:t>
+                <a:spcPts val="800"/>
+              </a:spcAft>
+              <a:defRPr sz="1600" b="1">
+                <a:solidFill>
+                  <a:srgbClr val="C0392B"/>
+                </a:solidFill>
+              </a:defRPr>
+            </a:pPr>
+            <a:r>
+              <a:t>▸ ★ 传输协议同构：complete(operation_id, system, user, response_schema)——六方法与两条路由零改动互换</a:t>
+            </a:r>
+          </a:p>
+          <a:p>
+            <a:pPr>
+              <a:spcAft>
+                <a:spcPts val="800"/>
+              </a:spcAft>
+              <a:defRPr sz="1400"/>
+            </a:pPr>
+            <a:r>
+              <a:t>· ClaudeCode 传输（CLI 会话凭据）与 OpenCode 传输（本地 server 代理 API key）</a:t>
+            </a:r>
+          </a:p>
+          <a:p>
+            <a:pPr>
+              <a:spcAft>
+                <a:spcPts val="800"/>
+              </a:spcAft>
+              <a:defRPr sz="1600"/>
+            </a:pPr>
+            <a:r>
+              <a:t>▸ 不确定付费调用语义：请求发出后状态不明 = PENDING，永不自动重试，须操作员对账</a:t>
+            </a:r>
+          </a:p>
+          <a:p>
+            <a:pPr>
+              <a:spcAft>
+                <a:spcPts val="800"/>
+              </a:spcAft>
+              <a:defRPr sz="1400"/>
+            </a:pPr>
+            <a:r>
+              <a:t>· 持久化熔断器：半开探测租约 + 冷却期，防模型故障拖垮整轮 run</a:t>
+            </a:r>
+          </a:p>
+          <a:p>
+            <a:pPr>
+              <a:spcAft>
+                <a:spcPts val="800"/>
+              </a:spcAft>
+              <a:defRPr sz="1600" b="1">
+                <a:solidFill>
+                  <a:srgbClr val="C0392B"/>
+                </a:solidFill>
+              </a:defRPr>
+            </a:pPr>
+            <a:r>
+              <a:t>▸ ★ 实证：同一套科学代码，Windows/Claude Code(Opus5) 与 Linux/opencode(GLM-5.3-Flash) 双平台双模型跑通</a:t>
+            </a:r>
+          </a:p>
+          <a:p>
+            <a:pPr>
+              <a:spcAft>
+                <a:spcPts val="800"/>
+              </a:spcAft>
+              <a:defRPr sz="1600"/>
+            </a:pPr>
+            <a:r>
+              <a:t>▸ 统一检索快照（内容寻址缓存 + 文件锁）：六方法相同查询相同证据，公平性由构造保证</a:t>
             </a:r>
           </a:p>
         </p:txBody>

</xml_diff>